<commit_message>
7-minute deck: three-panel fit-or-Occam slide
Slide 7 now shows, readout as is, the valid subspace against the manufactured
alignment and against the trained coupling map, plus the fair same-family
comparison (coupling map on the trained vs the untrained network), and drops
the temperature from the slide, references and speaker notes.
gain_decomposition_slide replaces gain_decomposition_as_is; the panel drawing
in fig_gain_decomposition.py is shared by all three figures (existing figures
unchanged).

Co-Authored-By: Claude Opus 5.5 <noreply@anthropic.com>
Claude-Session: https://claude.ai/code/session_01Qj3roUnnUMHLDdFNQo3cAK
</commit_message>
<xml_diff>
--- a/reports/talk_slt/slt_days_talk_7min.pptx
+++ b/reports/talk_slt/slt_days_talk_7min.pptx
@@ -132,7 +132,7 @@
   <p:extLst>
     <p:ext uri="{521415D9-36F7-43E2-AB2F-B90AF26B5E84}">
       <p14:sectionLst xmlns:p14="http://schemas.microsoft.com/office/powerpoint/2010/main">
-        <p14:section name="Talk" id="{c467c889-824d-1e46-fe8f-f1f5fcde3cde}">
+        <p14:section name="Talk" id="{6385446e-8ecf-ec88-d89d-6e5df65a44f5}">
           <p14:sldIdLst>
             <p14:sldId id="256"/>
             <p14:sldId id="257"/>
@@ -145,7 +145,7 @@
             <p14:sldId id="264"/>
           </p14:sldIdLst>
         </p14:section>
-        <p14:section name="Backup" id="{182ec8a6-5a66-7dea-a61e-8d8d76255cdc}">
+        <p14:section name="Backup" id="{4099838e-bd48-d6af-5376-f167536e76ad}">
           <p14:sldIdLst>
             <p14:sldId id="265"/>
             <p14:sldId id="266"/>
@@ -2594,7 +2594,7 @@
           <a:p>
             <a:r>
               <a:rPr lang="en-US" dirty="0"/>
-              <a:t>Which term of slide 4 carries the verdict? The gain of the valid layer-11 subspace, split into the fit term (pink: the difference of the best-in-family losses, linear in n) and the regret term (blue: the difference of the learning costs, kappa ln n); left against the manufactured alignment, right against the coupling map on the trained network; single-map MAP code, 32768 targets, three seeds. The regret term carries the gain. The fit term even runs against the valid subspace, and on the right it makes the coupling overtake near 20k targets. That is calibration: GPT-2 itself puts about 96 percent on the name, the subspace swap inherits that, the flows saturate the readout. Say: with one learned temperature per predictor the fit-term discrepancy disappears (fit term 0.0k against the forgery, -0.1k against the coupling; backup 'Fit or Occam: calibrated'). And the manufactured against the proper alignment with a coupling map for both, same family and parameter count, pays zero fit term: the entire 8k-bit difference is regret (backup 'Two coupling maps'). So the verdict between a valid and a manufactured explanation is a learning-coefficient statement. Caveat if asked: beyond about 32768 targets the optimiser's noise matters as much as kappa (backup 'To 131072 targets').</a:t>
+              <a:t>Which term of slide 4 carries the verdict? Each panel splits a gain into the fit term (pink: the difference of the best-in-family losses, linear in n) and the regret term (blue: the difference of the learning costs, delta kappa ln n); single-map MAP code, 32768 targets, three seeds. Left: the valid subspace against the manufactured alignment. The gain is carried by the regret term, and that term scales with the learning coefficient: this is where the investigation becomes a singular-learning-theory question. Middle: against the coupling map on the trained network. The gain is not monotonic in n: the fit term, linear in n, runs against the subspace at large n while the regret term grows only like ln n, so the gain peaks and turns over, and the coupling overtakes near 20k targets. With G(n) = n delta-l + delta-kappa ln n and a small negative delta-l the peak sits near n = delta-kappa / |delta-l| (back of the envelope for the left panel: delta-kappa about 750, |delta-l| about 0.04 nats per target, so about 2e4; the peak is at 16384). Right: the fair comparison, the same coupling map with the same parameter count on the trained and on the untrained network. Both fit equally well, the fit term is zero, and the whole 8k-bit gain is regret: kappa about 150 against about 830 per ln n. Parameter count, interchange accuracy and the best achievable loss cannot tell these two apart; the learning coefficient can. If asked why the flows fit better in the middle panel: calibration of the readout (backup 'Fit or Occam: calibrated'); beyond about 32768 targets the optimiser's noise matters as much as kappa (backup 'To 131072 targets').</a:t>
             </a:r>
             <a:endParaRPr lang="en-US" dirty="0"/>
           </a:p>
@@ -15616,7 +15616,7 @@
       </p:sp>
       <p:pic>
         <p:nvPicPr>
-          <p:cNvPr id="4" name="figure gain_decomposition_as_is.png" descr="gain_decomposition_as_is.png">    </p:cNvPr>
+          <p:cNvPr id="4" name="figure gain_decomposition_slide.png" descr="gain_decomposition_slide.png">    </p:cNvPr>
           <p:cNvPicPr>
             <a:picLocks noChangeAspect="1"/>
           </p:cNvPicPr>
@@ -15631,7 +15631,7 @@
         <p:spPr>
           <a:xfrm>
             <a:off x="457200" y="1371600"/>
-            <a:ext cx="11247120" cy="4066171"/>
+            <a:ext cx="11247120" cy="4370373"/>
           </a:xfrm>
           <a:prstGeom prst="rect">
             <a:avLst/>
@@ -15668,7 +15668,7 @@
                   <a:schemeClr val="tx2"/>
                 </a:solidFill>
               </a:rPr>
-              <a:t>Temperature scaling: Guo et al., ICML 2017</a:t>
+              <a:t>Free-energy expansion: Watanabe 2009</a:t>
             </a:r>
             <a:endParaRPr lang="en-US" sz="1100" dirty="0"/>
           </a:p>
@@ -15682,7 +15682,7 @@
                   <a:schemeClr val="tx2"/>
                 </a:solidFill>
               </a:rPr>
-              <a:t>Free-energy expansion: Watanabe 2009</a:t>
+              <a:t>Coupling-map alignments: Sutter et al., NeurIPS 2025</a:t>
             </a:r>
             <a:endParaRPr lang="en-US" sz="1100" dirty="0"/>
           </a:p>

</xml_diff>